<commit_message>
docs(bakeoff): 4-model PPT — fair direct+cache cost (sync with HTML)
Opus $52 (cache 52%), Sonnet $11.6 (cache 63%), multiples ~20x/~5x GLM;
footnote clarifying the 2026-07-02 direct-Anthropic re-measurement.

Co-Authored-By: Claude Opus 4.8 <noreply@anthropic.com>
</commit_message>
<xml_diff>
--- a/docs/LLM_BAKEOFF_4MODEL.pptx
+++ b/docs/LLM_BAKEOFF_4MODEL.pptx
@@ -3327,7 +3327,7 @@
                 </a:solidFill>
                 <a:latin typeface="Microsoft JhengHei"/>
               </a:rPr>
-              <a:t>Opus 4.8 品質天花板但 ~30× 成本 · Sonnet 5 被 GLM 支配 · KIMI 已淘汰</a:t>
+              <a:t>Opus 4.8 品質天花板但 ~20× 成本(direct+cache) · Sonnet 5 被 GLM 支配 · KIMI 已淘汰</a:t>
             </a:r>
           </a:p>
         </p:txBody>
@@ -4986,7 +4986,7 @@
                 </a:solidFill>
                 <a:latin typeface="Microsoft JhengHei"/>
               </a:rPr>
-              <a:t>0.9%</a:t>
+              <a:t>63%*</a:t>
             </a:r>
           </a:p>
         </p:txBody>
@@ -5028,7 +5028,7 @@
                 </a:solidFill>
                 <a:latin typeface="Microsoft JhengHei"/>
               </a:rPr>
-              <a:t>0%</a:t>
+              <a:t>52%*</a:t>
             </a:r>
           </a:p>
         </p:txBody>
@@ -5116,7 +5116,7 @@
                 </a:solidFill>
                 <a:latin typeface="Microsoft JhengHei"/>
               </a:rPr>
-              <a:t>成本/17 案</a:t>
+              <a:t>公平成本/17*</a:t>
             </a:r>
           </a:p>
         </p:txBody>
@@ -5242,7 +5242,7 @@
                 </a:solidFill>
                 <a:latin typeface="Microsoft JhengHei"/>
               </a:rPr>
-              <a:t>$18.7</a:t>
+              <a:t>$11.6*</a:t>
             </a:r>
           </a:p>
         </p:txBody>
@@ -5284,7 +5284,7 @@
                 </a:solidFill>
                 <a:latin typeface="Microsoft JhengHei"/>
               </a:rPr>
-              <a:t>$68.6</a:t>
+              <a:t>$52*</a:t>
             </a:r>
           </a:p>
         </p:txBody>
@@ -5498,7 +5498,7 @@
                 </a:solidFill>
                 <a:latin typeface="Microsoft JhengHei"/>
               </a:rPr>
-              <a:t>~9×</a:t>
+              <a:t>~5×</a:t>
             </a:r>
           </a:p>
         </p:txBody>
@@ -5540,7 +5540,7 @@
                 </a:solidFill>
                 <a:latin typeface="Microsoft JhengHei"/>
               </a:rPr>
-              <a:t>~30×</a:t>
+              <a:t>~20×</a:t>
             </a:r>
           </a:p>
         </p:txBody>
@@ -5810,7 +5810,7 @@
         <p:spPr>
           <a:xfrm>
             <a:off x="502920" y="6323075"/>
-            <a:ext cx="11155680" cy="822960"/>
+            <a:ext cx="11155680" cy="1005840"/>
           </a:xfrm>
           <a:prstGeom prst="rect">
             <a:avLst/>
@@ -5848,6 +5848,25 @@
                 <a:latin typeface="Microsoft JhengHei"/>
               </a:rPr>
               <a:t>xbar_r(只有 GLM+Opus 建對管制圖)、weco_rules(四家幾乎都漏 = 系統層弱點)。其餘 15 案四模型都對。</a:t>
+            </a:r>
+          </a:p>
+          <a:p>
+            <a:pPr algn="l">
+              <a:lnSpc>
+                <a:spcPct val="110000"/>
+              </a:lnSpc>
+              <a:spcAft>
+                <a:spcPts val="400"/>
+              </a:spcAft>
+            </a:pPr>
+            <a:r>
+              <a:rPr sz="1050" b="0">
+                <a:solidFill>
+                  <a:srgbClr val="667085"/>
+                </a:solidFill>
+                <a:latin typeface="Microsoft JhengHei"/>
+              </a:rPr>
+              <a:t>* Sonnet/Opus 成本與 cache 為 2026-07-02 direct Anthropic + cache 補測(公平值);bakeoff 當日走 OpenRouter 無 cache 為 $18.7 / $68.6。</a:t>
             </a:r>
           </a:p>
         </p:txBody>
@@ -14382,7 +14401,7 @@
                 </a:solidFill>
                 <a:latin typeface="Microsoft JhengHei"/>
               </a:rPr>
-              <a:t>0.9%</a:t>
+              <a:t>63%*</a:t>
             </a:r>
           </a:p>
           <a:p>
@@ -14410,7 +14429,7 @@
                 </a:solidFill>
                 <a:latin typeface="Microsoft JhengHei"/>
               </a:rPr>
-              <a:t>$18.7</a:t>
+              <a:t>$11.6*</a:t>
             </a:r>
           </a:p>
         </p:txBody>
@@ -14514,7 +14533,7 @@
                 </a:solidFill>
                 <a:latin typeface="Microsoft JhengHei"/>
               </a:rPr>
-              <a:t>嚴格 15/17(xbar_r 退化成折線)、成本 ~9× GLM。更貴又不更準,無採用理由。</a:t>
+              <a:t>嚴格 15/17(xbar_r 退化成折線)、direct+cache 成本 ~5× GLM。更貴又不更準,無採用理由。</a:t>
             </a:r>
           </a:p>
         </p:txBody>
@@ -18410,7 +18429,7 @@
                 </a:solidFill>
                 <a:latin typeface="Microsoft JhengHei"/>
               </a:rPr>
-              <a:t>0%</a:t>
+              <a:t>52%*</a:t>
             </a:r>
           </a:p>
           <a:p>
@@ -18438,7 +18457,7 @@
                 </a:solidFill>
                 <a:latin typeface="Microsoft JhengHei"/>
               </a:rPr>
-              <a:t>$68.6</a:t>
+              <a:t>$52*</a:t>
             </a:r>
           </a:p>
         </p:txBody>
@@ -18542,7 +18561,7 @@
                 </a:solidFill>
                 <a:latin typeface="Microsoft JhengHei"/>
               </a:rPr>
-              <a:t>嚴格 16/17 最高、最果斷(164 round),只漏 weco_rules。但 ~30× 成本、cache 失效。</a:t>
+              <a:t>嚴格 16/17 最高、最果斷(164 round),只漏 weco_rules。direct+cache 實測 ~20× GLM 成本。</a:t>
             </a:r>
           </a:p>
         </p:txBody>
@@ -22424,7 +22443,7 @@
                 </a:solidFill>
                 <a:latin typeface="Microsoft JhengHei"/>
               </a:rPr>
-              <a:t>嚴格 16/17 最高,但 ~30× 成本且 cache 走 OpenRouter 失效。只在 fleet/composite/特定管制圖人工升級時叫用,且走 direct Anthropic 恢復 cache。</a:t>
+              <a:t>嚴格 16/17 最高。direct+cache 實測 ~20× GLM 成本。只在 fleet/composite/特定管制圖人工升級時叫用,且走 direct Anthropic 才有 cache。</a:t>
             </a:r>
           </a:p>
         </p:txBody>
@@ -22531,7 +22550,7 @@
                 </a:solidFill>
                 <a:latin typeface="Microsoft JhengHei"/>
               </a:rPr>
-              <a:t>嚴格 15/17(xbar_r 退化),成本 ~9× GLM。比 GLM 貴又不更準。</a:t>
+              <a:t>嚴格 15/17(xbar_r 退化),direct+cache 成本仍 ~5× GLM。比 GLM 貴又不更準。</a:t>
             </a:r>
           </a:p>
         </p:txBody>

</xml_diff>